<commit_message>
Tuto Python pour fonctionnement asynchrone
</commit_message>
<xml_diff>
--- a/LLM.pptx
+++ b/LLM.pptx
@@ -104,6 +104,11 @@
       </a:defRPr>
     </a:lvl9pPr>
   </p:defaultTextStyle>
+  <p:extLst>
+    <p:ext uri="{EFAFB233-063F-42B5-8137-9DF3F51BA10A}">
+      <p15:sldGuideLst xmlns:p15="http://schemas.microsoft.com/office/powerpoint/2012/main"/>
+    </p:ext>
+  </p:extLst>
 </p:presentation>
 </file>
 
@@ -238,7 +243,7 @@
           <a:p>
             <a:fld id="{CB7C6F10-3D38-423D-8A72-C1177D22B252}" type="datetimeFigureOut">
               <a:rPr lang="fr-FR" smtClean="0"/>
-              <a:t>23/06/2026</a:t>
+              <a:t>26/06/2026</a:t>
             </a:fld>
             <a:endParaRPr lang="fr-FR"/>
           </a:p>
@@ -408,7 +413,7 @@
           <a:p>
             <a:fld id="{CB7C6F10-3D38-423D-8A72-C1177D22B252}" type="datetimeFigureOut">
               <a:rPr lang="fr-FR" smtClean="0"/>
-              <a:t>23/06/2026</a:t>
+              <a:t>26/06/2026</a:t>
             </a:fld>
             <a:endParaRPr lang="fr-FR"/>
           </a:p>
@@ -588,7 +593,7 @@
           <a:p>
             <a:fld id="{CB7C6F10-3D38-423D-8A72-C1177D22B252}" type="datetimeFigureOut">
               <a:rPr lang="fr-FR" smtClean="0"/>
-              <a:t>23/06/2026</a:t>
+              <a:t>26/06/2026</a:t>
             </a:fld>
             <a:endParaRPr lang="fr-FR"/>
           </a:p>
@@ -758,7 +763,7 @@
           <a:p>
             <a:fld id="{CB7C6F10-3D38-423D-8A72-C1177D22B252}" type="datetimeFigureOut">
               <a:rPr lang="fr-FR" smtClean="0"/>
-              <a:t>23/06/2026</a:t>
+              <a:t>26/06/2026</a:t>
             </a:fld>
             <a:endParaRPr lang="fr-FR"/>
           </a:p>
@@ -1004,7 +1009,7 @@
           <a:p>
             <a:fld id="{CB7C6F10-3D38-423D-8A72-C1177D22B252}" type="datetimeFigureOut">
               <a:rPr lang="fr-FR" smtClean="0"/>
-              <a:t>23/06/2026</a:t>
+              <a:t>26/06/2026</a:t>
             </a:fld>
             <a:endParaRPr lang="fr-FR"/>
           </a:p>
@@ -1236,7 +1241,7 @@
           <a:p>
             <a:fld id="{CB7C6F10-3D38-423D-8A72-C1177D22B252}" type="datetimeFigureOut">
               <a:rPr lang="fr-FR" smtClean="0"/>
-              <a:t>23/06/2026</a:t>
+              <a:t>26/06/2026</a:t>
             </a:fld>
             <a:endParaRPr lang="fr-FR"/>
           </a:p>
@@ -1603,7 +1608,7 @@
           <a:p>
             <a:fld id="{CB7C6F10-3D38-423D-8A72-C1177D22B252}" type="datetimeFigureOut">
               <a:rPr lang="fr-FR" smtClean="0"/>
-              <a:t>23/06/2026</a:t>
+              <a:t>26/06/2026</a:t>
             </a:fld>
             <a:endParaRPr lang="fr-FR"/>
           </a:p>
@@ -1721,7 +1726,7 @@
           <a:p>
             <a:fld id="{CB7C6F10-3D38-423D-8A72-C1177D22B252}" type="datetimeFigureOut">
               <a:rPr lang="fr-FR" smtClean="0"/>
-              <a:t>23/06/2026</a:t>
+              <a:t>26/06/2026</a:t>
             </a:fld>
             <a:endParaRPr lang="fr-FR"/>
           </a:p>
@@ -1816,7 +1821,7 @@
           <a:p>
             <a:fld id="{CB7C6F10-3D38-423D-8A72-C1177D22B252}" type="datetimeFigureOut">
               <a:rPr lang="fr-FR" smtClean="0"/>
-              <a:t>23/06/2026</a:t>
+              <a:t>26/06/2026</a:t>
             </a:fld>
             <a:endParaRPr lang="fr-FR"/>
           </a:p>
@@ -2093,7 +2098,7 @@
           <a:p>
             <a:fld id="{CB7C6F10-3D38-423D-8A72-C1177D22B252}" type="datetimeFigureOut">
               <a:rPr lang="fr-FR" smtClean="0"/>
-              <a:t>23/06/2026</a:t>
+              <a:t>26/06/2026</a:t>
             </a:fld>
             <a:endParaRPr lang="fr-FR"/>
           </a:p>
@@ -2346,7 +2351,7 @@
           <a:p>
             <a:fld id="{CB7C6F10-3D38-423D-8A72-C1177D22B252}" type="datetimeFigureOut">
               <a:rPr lang="fr-FR" smtClean="0"/>
-              <a:t>23/06/2026</a:t>
+              <a:t>26/06/2026</a:t>
             </a:fld>
             <a:endParaRPr lang="fr-FR"/>
           </a:p>
@@ -2559,7 +2564,7 @@
           <a:p>
             <a:fld id="{CB7C6F10-3D38-423D-8A72-C1177D22B252}" type="datetimeFigureOut">
               <a:rPr lang="fr-FR" smtClean="0"/>
-              <a:t>23/06/2026</a:t>
+              <a:t>26/06/2026</a:t>
             </a:fld>
             <a:endParaRPr lang="fr-FR"/>
           </a:p>
@@ -3261,7 +3266,6 @@
               <a:rPr lang="fr-FR" dirty="0" smtClean="0"/>
               <a:t>On ne cherche jamais à comprendre les mots ni les morceaux de mots !!!</a:t>
             </a:r>
-            <a:endParaRPr lang="fr-FR" dirty="0" smtClean="0"/>
           </a:p>
         </p:txBody>
       </p:sp>
@@ -3392,7 +3396,7 @@
         </p:nvSpPr>
         <p:spPr>
           <a:xfrm>
-            <a:off x="1081658" y="4825879"/>
+            <a:off x="1194947" y="4825879"/>
             <a:ext cx="7426072" cy="1846659"/>
           </a:xfrm>
           <a:prstGeom prst="rect">
@@ -3569,16 +3573,13 @@
       <p:cxnSp>
         <p:nvCxnSpPr>
           <p:cNvPr id="28" name="Connecteur en arc 27"/>
-          <p:cNvCxnSpPr>
-            <a:stCxn id="5" idx="2"/>
-            <a:endCxn id="20" idx="0"/>
-          </p:cNvCxnSpPr>
+          <p:cNvCxnSpPr/>
           <p:nvPr/>
         </p:nvCxnSpPr>
         <p:spPr>
           <a:xfrm rot="5400000">
-            <a:off x="5965272" y="3074878"/>
-            <a:ext cx="580423" cy="2921578"/>
+            <a:off x="6136718" y="3032906"/>
+            <a:ext cx="399373" cy="2808289"/>
           </a:xfrm>
           <a:prstGeom prst="curvedConnector3">
             <a:avLst>
@@ -3651,7 +3652,6 @@
               <a:rPr lang="fr-FR" dirty="0" smtClean="0"/>
               <a:t>Il n’y a jamais aucune compréhension des textes considérés, uniquement une association logique et probabiliste</a:t>
             </a:r>
-            <a:endParaRPr lang="fr-FR" dirty="0" smtClean="0"/>
           </a:p>
         </p:txBody>
       </p:sp>
@@ -3663,7 +3663,7 @@
         </p:nvSpPr>
         <p:spPr>
           <a:xfrm>
-            <a:off x="8150086" y="1248354"/>
+            <a:off x="8093442" y="1191710"/>
             <a:ext cx="2098651" cy="1446550"/>
           </a:xfrm>
           <a:prstGeom prst="rect">
@@ -3690,6 +3690,99 @@
                 <a:srgbClr val="FF0000"/>
               </a:solidFill>
             </a:endParaRPr>
+          </a:p>
+        </p:txBody>
+      </p:sp>
+      <p:sp>
+        <p:nvSpPr>
+          <p:cNvPr id="2" name="ZoneTexte 1"/>
+          <p:cNvSpPr txBox="1"/>
+          <p:nvPr/>
+        </p:nvSpPr>
+        <p:spPr>
+          <a:xfrm>
+            <a:off x="7493788" y="2504450"/>
+            <a:ext cx="3684663" cy="369332"/>
+          </a:xfrm>
+          <a:prstGeom prst="rect">
+            <a:avLst/>
+          </a:prstGeom>
+          <a:noFill/>
+        </p:spPr>
+        <p:txBody>
+          <a:bodyPr wrap="none" rtlCol="0">
+            <a:spAutoFit/>
+          </a:bodyPr>
+          <a:lstStyle/>
+          <a:p>
+            <a:r>
+              <a:rPr lang="fr-FR" dirty="0" err="1" smtClean="0">
+                <a:solidFill>
+                  <a:srgbClr val="00B0F0"/>
+                </a:solidFill>
+              </a:rPr>
+              <a:t>chatGPT</a:t>
+            </a:r>
+            <a:r>
+              <a:rPr lang="fr-FR" dirty="0" smtClean="0">
+                <a:solidFill>
+                  <a:srgbClr val="00B0F0"/>
+                </a:solidFill>
+              </a:rPr>
+              <a:t>, Claude, Copilote, Le Chat, …</a:t>
+            </a:r>
+            <a:endParaRPr lang="fr-FR" dirty="0">
+              <a:solidFill>
+                <a:srgbClr val="00B0F0"/>
+              </a:solidFill>
+            </a:endParaRPr>
+          </a:p>
+        </p:txBody>
+      </p:sp>
+      <p:sp>
+        <p:nvSpPr>
+          <p:cNvPr id="12" name="Rectangle à coins arrondis 11"/>
+          <p:cNvSpPr/>
+          <p:nvPr/>
+        </p:nvSpPr>
+        <p:spPr>
+          <a:xfrm>
+            <a:off x="140426" y="3859899"/>
+            <a:ext cx="3727567" cy="623087"/>
+          </a:xfrm>
+          <a:prstGeom prst="wedgeRoundRectCallout">
+            <a:avLst>
+              <a:gd name="adj1" fmla="val 69594"/>
+              <a:gd name="adj2" fmla="val 111811"/>
+              <a:gd name="adj3" fmla="val 16667"/>
+            </a:avLst>
+          </a:prstGeom>
+        </p:spPr>
+        <p:style>
+          <a:lnRef idx="2">
+            <a:schemeClr val="accent1">
+              <a:shade val="50000"/>
+            </a:schemeClr>
+          </a:lnRef>
+          <a:fillRef idx="1">
+            <a:schemeClr val="accent1"/>
+          </a:fillRef>
+          <a:effectRef idx="0">
+            <a:schemeClr val="accent1"/>
+          </a:effectRef>
+          <a:fontRef idx="minor">
+            <a:schemeClr val="lt1"/>
+          </a:fontRef>
+        </p:style>
+        <p:txBody>
+          <a:bodyPr rtlCol="0" anchor="ctr"/>
+          <a:lstStyle/>
+          <a:p>
+            <a:r>
+              <a:rPr lang="fr-FR" dirty="0" smtClean="0"/>
+              <a:t>Le contexte est l’ensemble de la base d’apprentissage et du prompt</a:t>
+            </a:r>
+            <a:endParaRPr lang="fr-FR" dirty="0" smtClean="0"/>
           </a:p>
         </p:txBody>
       </p:sp>

</xml_diff>